<commit_message>
feat(v1.1): add batch editing tools, filtered inspection, paragraph preservation, container-aware validation, and Antigravity sync scripts
</commit_message>
<xml_diff>
--- a/inputs/DaaS_Release_Platform_updated_Flow_FIXED.pptx
+++ b/inputs/DaaS_Release_Platform_updated_Flow_FIXED.pptx
@@ -45873,29 +45873,29 @@
               <a:buNone/>
             </a:pPr>
             <a:r>
-              <a:rPr sz="950" b="1">
+              <a:rPr lang="en-US" sz="820" b="1" dirty="0">
                 <a:solidFill>
                   <a:srgbClr val="2F55C4"/>
                 </a:solidFill>
-                <a:latin typeface="Calibri"/>
+                <a:latin typeface="Calibri" pitchFamily="34" charset="0"/>
               </a:rPr>
               <a:t>DAAS PLATFORM</a:t>
             </a:r>
             <a:r>
-              <a:rPr sz="950" b="0">
+              <a:rPr lang="en-US" sz="820" b="0" dirty="0">
                 <a:solidFill>
                   <a:srgbClr val="A9B6CC"/>
                 </a:solidFill>
-                <a:latin typeface="Calibri"/>
+                <a:latin typeface="Calibri" pitchFamily="34" charset="0"/>
               </a:rPr>
               <a:t>   ·   </a:t>
             </a:r>
             <a:r>
-              <a:rPr sz="950" b="1">
+              <a:rPr lang="en-US" sz="820" b="1" dirty="0">
                 <a:solidFill>
                   <a:srgbClr val="2F55C4"/>
                 </a:solidFill>
-                <a:latin typeface="Calibri"/>
+                <a:latin typeface="Calibri" pitchFamily="34" charset="0"/>
               </a:rPr>
               <a:t>PLATFORM OVERVIEW</a:t>
             </a:r>
@@ -45931,13 +45931,37 @@
               <a:buNone/>
             </a:pPr>
             <a:r>
-              <a:rPr sz="2200" b="1">
+              <a:rPr lang="en-US" sz="1600" b="1" i="0">
                 <a:solidFill>
                   <a:srgbClr val="0F1B35"/>
                 </a:solidFill>
                 <a:latin typeface="Calibri"/>
+                <a:ea typeface="Calibri"/>
+                <a:cs typeface="Calibri"/>
               </a:rPr>
-              <a:t>What Is DaaS?</a:t>
+              <a:t>What </a:t>
+            </a:r>
+            <a:r>
+              <a:rPr lang="en-US" sz="1600" b="1">
+                <a:solidFill>
+                  <a:srgbClr val="0F1B35"/>
+                </a:solidFill>
+                <a:latin typeface="Calibri"/>
+                <a:ea typeface="Calibri"/>
+                <a:cs typeface="Calibri"/>
+              </a:rPr>
+              <a:t>Is</a:t>
+            </a:r>
+            <a:r>
+              <a:rPr lang="en-US" sz="1600" b="1" i="0">
+                <a:solidFill>
+                  <a:srgbClr val="0F1B35"/>
+                </a:solidFill>
+                <a:latin typeface="Calibri"/>
+                <a:ea typeface="Calibri"/>
+                <a:cs typeface="Calibri"/>
+              </a:rPr>
+              <a:t> DaaS?</a:t>
             </a:r>
           </a:p>
         </p:txBody>
@@ -45971,13 +45995,15 @@
               <a:buNone/>
             </a:pPr>
             <a:r>
-              <a:rPr sz="850" b="0">
+              <a:rPr lang="en-US" sz="750" b="0" i="0">
                 <a:solidFill>
                   <a:srgbClr val="5B6584"/>
                 </a:solidFill>
                 <a:latin typeface="Calibri"/>
+                <a:ea typeface="Calibri"/>
+                <a:cs typeface="Calibri"/>
               </a:rPr>
-              <a:t>Deployment as a Service</a:t>
+              <a:t>Deployment as a Service </a:t>
             </a:r>
             <a:endParaRPr lang="en-US" sz="780" b="0" i="0" dirty="0">
               <a:solidFill>
@@ -46017,11 +46043,11 @@
               <a:buNone/>
             </a:pPr>
             <a:r>
-              <a:rPr sz="850" b="0">
+              <a:rPr lang="en-US" sz="780" b="0" i="0" dirty="0">
                 <a:solidFill>
                   <a:srgbClr val="5B6584"/>
                 </a:solidFill>
-                <a:latin typeface="Calibri"/>
+                <a:latin typeface="Calibri" pitchFamily="34" charset="0"/>
               </a:rPr>
               <a:t>2</a:t>
             </a:r>
@@ -46124,20 +46150,20 @@
               <a:buNone/>
             </a:pPr>
             <a:r>
-              <a:rPr sz="1150" b="1">
+              <a:rPr lang="en-US" sz="980" b="1" dirty="0">
                 <a:solidFill>
                   <a:srgbClr val="0F1B35"/>
                 </a:solidFill>
-                <a:latin typeface="Calibri"/>
+                <a:latin typeface="Calibri" pitchFamily="34" charset="0"/>
               </a:rPr>
               <a:t>ADaaS — Agentic Deployment as a Service, or DaaS for short — </a:t>
             </a:r>
             <a:r>
-              <a:rPr sz="1150" b="0">
-                <a:solidFill>
-                  <a:srgbClr val="0F1B35"/>
-                </a:solidFill>
-                <a:latin typeface="Calibri"/>
+              <a:rPr lang="en-US" sz="980" b="0" dirty="0">
+                <a:solidFill>
+                  <a:srgbClr val="1B1F3B"/>
+                </a:solidFill>
+                <a:latin typeface="Calibri" pitchFamily="34" charset="0"/>
               </a:rPr>
               <a:t>is an AI-driven release automation platform — one governed engine that runs every deployment.</a:t>
             </a:r>
@@ -46171,29 +46197,29 @@
               <a:buNone/>
             </a:pPr>
             <a:r>
-              <a:rPr sz="1050" b="0">
+              <a:rPr lang="en-US" sz="880" b="0" dirty="0">
                 <a:solidFill>
                   <a:srgbClr val="5B6584"/>
                 </a:solidFill>
-                <a:latin typeface="Calibri"/>
+                <a:latin typeface="Calibri" pitchFamily="34" charset="0"/>
               </a:rPr>
               <a:t>It replaces manual, error-prone releases with an </a:t>
             </a:r>
             <a:r>
-              <a:rPr sz="1050" b="1">
-                <a:solidFill>
-                  <a:srgbClr val="0F1B35"/>
-                </a:solidFill>
-                <a:latin typeface="Calibri"/>
+              <a:rPr lang="en-US" sz="880" b="1" dirty="0">
+                <a:solidFill>
+                  <a:srgbClr val="5B6584"/>
+                </a:solidFill>
+                <a:latin typeface="Calibri" pitchFamily="34" charset="0"/>
               </a:rPr>
               <a:t>agent-orchestrated pipeline</a:t>
             </a:r>
             <a:r>
-              <a:rPr sz="1050" b="0">
+              <a:rPr lang="en-US" sz="880" b="0" dirty="0">
                 <a:solidFill>
                   <a:srgbClr val="5B6584"/>
                 </a:solidFill>
-                <a:latin typeface="Calibri"/>
+                <a:latin typeface="Calibri" pitchFamily="34" charset="0"/>
               </a:rPr>
               <a:t> — the same core every time, configured differently for every client. Nothing about the workflow is hard-coded.</a:t>
             </a:r>
@@ -46229,11 +46255,11 @@
               <a:buNone/>
             </a:pPr>
             <a:r>
-              <a:rPr sz="900" b="1">
+              <a:rPr lang="en-US" sz="730" b="1" i="0" spc="130" dirty="0">
                 <a:solidFill>
                   <a:srgbClr val="5B6584"/>
                 </a:solidFill>
-                <a:latin typeface="Calibri"/>
+                <a:latin typeface="Calibri" pitchFamily="34" charset="0"/>
               </a:rPr>
               <a:t>SET UP ONCE PER CLIENT   →</a:t>
             </a:r>
@@ -46269,11 +46295,11 @@
               <a:buNone/>
             </a:pPr>
             <a:r>
-              <a:rPr sz="950" b="1">
+              <a:rPr lang="en-US" sz="760" b="1" i="0" spc="150" dirty="0">
                 <a:solidFill>
                   <a:srgbClr val="0F1B35"/>
                 </a:solidFill>
-                <a:latin typeface="Calibri"/>
+                <a:latin typeface="Calibri" pitchFamily="34" charset="0"/>
               </a:rPr>
               <a:t>THE CORE</a:t>
             </a:r>
@@ -46309,11 +46335,11 @@
               <a:buNone/>
             </a:pPr>
             <a:r>
-              <a:rPr sz="850" b="1">
-                <a:solidFill>
-                  <a:srgbClr val="7887A5"/>
-                </a:solidFill>
-                <a:latin typeface="Calibri"/>
+              <a:rPr lang="en-US" sz="680" b="1" i="0" spc="90" dirty="0">
+                <a:solidFill>
+                  <a:srgbClr val="8A97AE"/>
+                </a:solidFill>
+                <a:latin typeface="Calibri" pitchFamily="34" charset="0"/>
               </a:rPr>
               <a:t>EVERY RELEASE RUNS HERE</a:t>
             </a:r>
@@ -46349,11 +46375,11 @@
               <a:buNone/>
             </a:pPr>
             <a:r>
-              <a:rPr sz="900" b="1">
+              <a:rPr lang="en-US" sz="730" b="1" i="0" spc="130" dirty="0">
                 <a:solidFill>
                   <a:srgbClr val="5B6584"/>
                 </a:solidFill>
-                <a:latin typeface="Calibri"/>
+                <a:latin typeface="Calibri" pitchFamily="34" charset="0"/>
               </a:rPr>
               <a:t>←   GOVERNS &amp; REPORTS</a:t>
             </a:r>
@@ -46447,11 +46473,11 @@
               <a:buNone/>
             </a:pPr>
             <a:r>
-              <a:rPr sz="950" b="1">
+              <a:rPr lang="en-US" sz="690" b="1" i="0" dirty="0">
                 <a:solidFill>
                   <a:srgbClr val="FFFFFF"/>
                 </a:solidFill>
-                <a:latin typeface="Calibri"/>
+                <a:latin typeface="Calibri" pitchFamily="34" charset="0"/>
               </a:rPr>
               <a:t>1</a:t>
             </a:r>
@@ -46487,11 +46513,11 @@
               <a:buNone/>
             </a:pPr>
             <a:r>
-              <a:rPr sz="1250" b="1">
+              <a:rPr lang="en-US" sz="1010" b="1" i="0" dirty="0">
                 <a:solidFill>
                   <a:srgbClr val="0F1B35"/>
                 </a:solidFill>
-                <a:latin typeface="Calibri"/>
+                <a:latin typeface="Calibri" pitchFamily="34" charset="0"/>
               </a:rPr>
               <a:t>Application</a:t>
             </a:r>
@@ -46527,11 +46553,11 @@
               <a:buNone/>
             </a:pPr>
             <a:r>
-              <a:rPr sz="980" b="0">
+              <a:rPr lang="en-US" sz="750" b="0" i="0" dirty="0">
                 <a:solidFill>
                   <a:srgbClr val="5B6584"/>
                 </a:solidFill>
-                <a:latin typeface="Calibri"/>
+                <a:latin typeface="Calibri" pitchFamily="34" charset="0"/>
               </a:rPr>
               <a:t>Where a release enters — change ticket, pipeline trigger, or manual run.</a:t>
             </a:r>
@@ -46676,11 +46702,11 @@
               <a:buNone/>
             </a:pPr>
             <a:r>
-              <a:rPr sz="950" b="1">
+              <a:rPr lang="en-US" sz="690" b="1" i="0" dirty="0">
                 <a:solidFill>
                   <a:srgbClr val="FFFFFF"/>
                 </a:solidFill>
-                <a:latin typeface="Calibri"/>
+                <a:latin typeface="Calibri" pitchFamily="34" charset="0"/>
               </a:rPr>
               <a:t>2</a:t>
             </a:r>
@@ -46716,11 +46742,11 @@
               <a:buNone/>
             </a:pPr>
             <a:r>
-              <a:rPr sz="1250" b="1">
+              <a:rPr lang="en-US" sz="1010" b="1" i="0" dirty="0">
                 <a:solidFill>
                   <a:srgbClr val="0F1B35"/>
                 </a:solidFill>
-                <a:latin typeface="Calibri"/>
+                <a:latin typeface="Calibri" pitchFamily="34" charset="0"/>
               </a:rPr>
               <a:t>Workflow</a:t>
             </a:r>
@@ -46756,11 +46782,11 @@
               <a:buNone/>
             </a:pPr>
             <a:r>
-              <a:rPr sz="980" b="0">
-                <a:solidFill>
-                  <a:srgbClr val="5B6584"/>
-                </a:solidFill>
-                <a:latin typeface="Calibri"/>
+              <a:rPr lang="en-US" sz="750" b="0" i="0" dirty="0">
+                <a:solidFill>
+                  <a:srgbClr val="2E4270"/>
+                </a:solidFill>
+                <a:latin typeface="Calibri" pitchFamily="34" charset="0"/>
               </a:rPr>
               <a:t>Resolves which phases, approvals and templates apply to this release.</a:t>
             </a:r>
@@ -46905,11 +46931,11 @@
               <a:buNone/>
             </a:pPr>
             <a:r>
-              <a:rPr sz="950" b="1">
+              <a:rPr lang="en-US" sz="690" b="1" i="0" dirty="0">
                 <a:solidFill>
                   <a:srgbClr val="0F1B35"/>
                 </a:solidFill>
-                <a:latin typeface="Calibri"/>
+                <a:latin typeface="Calibri" pitchFamily="34" charset="0"/>
               </a:rPr>
               <a:t>3</a:t>
             </a:r>
@@ -46945,11 +46971,11 @@
               <a:buNone/>
             </a:pPr>
             <a:r>
-              <a:rPr sz="1250" b="1">
+              <a:rPr lang="en-US" sz="1010" b="1" i="0" dirty="0">
                 <a:solidFill>
                   <a:srgbClr val="FFFFFF"/>
                 </a:solidFill>
-                <a:latin typeface="Calibri"/>
+                <a:latin typeface="Calibri" pitchFamily="34" charset="0"/>
               </a:rPr>
               <a:t>Agents &amp; Orchestration</a:t>
             </a:r>
@@ -46985,13 +47011,26 @@
               <a:buNone/>
             </a:pPr>
             <a:r>
-              <a:rPr sz="919" b="0">
-                <a:solidFill>
-                  <a:srgbClr val="D9E5F8"/>
+              <a:rPr lang="en-US" sz="700">
+                <a:solidFill>
+                  <a:srgbClr val="E1EAF9"/>
                 </a:solidFill>
                 <a:latin typeface="Calibri"/>
+                <a:ea typeface="Calibri"/>
+                <a:cs typeface="Calibri"/>
               </a:rPr>
-              <a:t>Specialized agents run in sequence on every release.</a:t>
+              <a:t>Specialized</a:t>
+            </a:r>
+            <a:r>
+              <a:rPr lang="en-US" sz="700" b="0" i="0" dirty="0">
+                <a:solidFill>
+                  <a:srgbClr val="E1EAF9"/>
+                </a:solidFill>
+                <a:latin typeface="Calibri"/>
+                <a:ea typeface="Calibri"/>
+                <a:cs typeface="Calibri"/>
+              </a:rPr>
+              <a:t> agents run in sequence on every release.</a:t>
             </a:r>
           </a:p>
         </p:txBody>
@@ -47058,11 +47097,11 @@
               <a:buNone/>
             </a:pPr>
             <a:r>
-              <a:rPr sz="850" b="1">
-                <a:solidFill>
-                  <a:srgbClr val="FFFFFF"/>
-                </a:solidFill>
-                <a:latin typeface="Calibri"/>
+              <a:rPr lang="en-US" sz="670" b="0" i="0" dirty="0">
+                <a:solidFill>
+                  <a:srgbClr val="E4ECFA"/>
+                </a:solidFill>
+                <a:latin typeface="Calibri" pitchFamily="34" charset="0"/>
               </a:rPr>
               <a:t>Scan</a:t>
             </a:r>
@@ -47131,11 +47170,11 @@
               <a:buNone/>
             </a:pPr>
             <a:r>
-              <a:rPr sz="850" b="1">
-                <a:solidFill>
-                  <a:srgbClr val="FFFFFF"/>
-                </a:solidFill>
-                <a:latin typeface="Calibri"/>
+              <a:rPr lang="en-US" sz="670" b="0" i="0" dirty="0">
+                <a:solidFill>
+                  <a:srgbClr val="E4ECFA"/>
+                </a:solidFill>
+                <a:latin typeface="Calibri" pitchFamily="34" charset="0"/>
               </a:rPr>
               <a:t>Compare</a:t>
             </a:r>
@@ -47204,11 +47243,11 @@
               <a:buNone/>
             </a:pPr>
             <a:r>
-              <a:rPr sz="850" b="1">
-                <a:solidFill>
-                  <a:srgbClr val="FFFFFF"/>
-                </a:solidFill>
-                <a:latin typeface="Calibri"/>
+              <a:rPr lang="en-US" sz="670" b="0" i="0" dirty="0">
+                <a:solidFill>
+                  <a:srgbClr val="E4ECFA"/>
+                </a:solidFill>
+                <a:latin typeface="Calibri" pitchFamily="34" charset="0"/>
               </a:rPr>
               <a:t>Dependency</a:t>
             </a:r>
@@ -47277,11 +47316,11 @@
               <a:buNone/>
             </a:pPr>
             <a:r>
-              <a:rPr sz="850" b="1">
-                <a:solidFill>
-                  <a:srgbClr val="FFFFFF"/>
-                </a:solidFill>
-                <a:latin typeface="Calibri"/>
+              <a:rPr lang="en-US" sz="670" b="0" i="0" dirty="0">
+                <a:solidFill>
+                  <a:srgbClr val="E4ECFA"/>
+                </a:solidFill>
+                <a:latin typeface="Calibri" pitchFamily="34" charset="0"/>
               </a:rPr>
               <a:t>Readiness</a:t>
             </a:r>
@@ -47350,11 +47389,11 @@
               <a:buNone/>
             </a:pPr>
             <a:r>
-              <a:rPr sz="850" b="1">
-                <a:solidFill>
-                  <a:srgbClr val="FFFFFF"/>
-                </a:solidFill>
-                <a:latin typeface="Calibri"/>
+              <a:rPr lang="en-US" sz="670" b="0" i="0" dirty="0">
+                <a:solidFill>
+                  <a:srgbClr val="E4ECFA"/>
+                </a:solidFill>
+                <a:latin typeface="Calibri" pitchFamily="34" charset="0"/>
               </a:rPr>
               <a:t>Risk</a:t>
             </a:r>
@@ -47423,11 +47462,11 @@
               <a:buNone/>
             </a:pPr>
             <a:r>
-              <a:rPr sz="850" b="1">
-                <a:solidFill>
-                  <a:srgbClr val="FFFFFF"/>
-                </a:solidFill>
-                <a:latin typeface="Calibri"/>
+              <a:rPr lang="en-US" sz="670" b="0" i="0" dirty="0">
+                <a:solidFill>
+                  <a:srgbClr val="E4ECFA"/>
+                </a:solidFill>
+                <a:latin typeface="Calibri" pitchFamily="34" charset="0"/>
               </a:rPr>
               <a:t>Validate</a:t>
             </a:r>
@@ -47572,11 +47611,11 @@
               <a:buNone/>
             </a:pPr>
             <a:r>
-              <a:rPr sz="950" b="1">
+              <a:rPr lang="en-US" sz="690" b="1" i="0" dirty="0">
                 <a:solidFill>
                   <a:srgbClr val="0F1B35"/>
                 </a:solidFill>
-                <a:latin typeface="Calibri"/>
+                <a:latin typeface="Calibri" pitchFamily="34" charset="0"/>
               </a:rPr>
               <a:t>4</a:t>
             </a:r>
@@ -47612,11 +47651,11 @@
               <a:buNone/>
             </a:pPr>
             <a:r>
-              <a:rPr sz="1250" b="1">
+              <a:rPr lang="en-US" sz="1010" b="1" i="0" dirty="0">
                 <a:solidFill>
                   <a:srgbClr val="FFFFFF"/>
                 </a:solidFill>
-                <a:latin typeface="Calibri"/>
+                <a:latin typeface="Calibri" pitchFamily="34" charset="0"/>
               </a:rPr>
               <a:t>Infrastructure &amp; Cloud</a:t>
             </a:r>
@@ -47652,11 +47691,11 @@
               <a:buNone/>
             </a:pPr>
             <a:r>
-              <a:rPr sz="980" b="0">
-                <a:solidFill>
-                  <a:srgbClr val="D9E5F8"/>
-                </a:solidFill>
-                <a:latin typeface="Calibri"/>
+              <a:rPr lang="en-US" sz="750" b="0" i="0" dirty="0">
+                <a:solidFill>
+                  <a:srgbClr val="CADCFC"/>
+                </a:solidFill>
+                <a:latin typeface="Calibri" pitchFamily="34" charset="0"/>
               </a:rPr>
               <a:t>The live cloud resources and pipelines the change is applied to — the base.</a:t>
             </a:r>
@@ -47792,11 +47831,11 @@
               <a:buNone/>
             </a:pPr>
             <a:r>
-              <a:rPr sz="1100" b="1">
+              <a:rPr lang="en-US" sz="890" b="1" i="0" dirty="0">
                 <a:solidFill>
                   <a:srgbClr val="FFFFFF"/>
                 </a:solidFill>
-                <a:latin typeface="Calibri"/>
+                <a:latin typeface="Calibri" pitchFamily="34" charset="0"/>
               </a:rPr>
               <a:t>1</a:t>
             </a:r>
@@ -47832,11 +47871,11 @@
               <a:buNone/>
             </a:pPr>
             <a:r>
-              <a:rPr sz="1400" b="1">
-                <a:solidFill>
-                  <a:srgbClr val="B67700"/>
-                </a:solidFill>
-                <a:latin typeface="Calibri"/>
+              <a:rPr lang="en-US" sz="1120" b="1" i="0" dirty="0">
+                <a:solidFill>
+                  <a:srgbClr val="B8790F"/>
+                </a:solidFill>
+                <a:latin typeface="Calibri" pitchFamily="34" charset="0"/>
               </a:rPr>
               <a:t>Analyse</a:t>
             </a:r>
@@ -47899,11 +47938,11 @@
               <a:buChar char="•"/>
             </a:pPr>
             <a:r>
-              <a:rPr sz="1000" b="0">
+              <a:rPr lang="en-US" sz="820" dirty="0">
                 <a:solidFill>
                   <a:srgbClr val="1B1F3B"/>
                 </a:solidFill>
-                <a:latin typeface="Calibri"/>
+                <a:latin typeface="Calibri" pitchFamily="34" charset="0"/>
               </a:rPr>
               <a:t>Maps the client’s cloud, CI/CD, ticketing and approval chain before anything is wired.</a:t>
             </a:r>
@@ -47920,11 +47959,11 @@
               <a:buChar char="•"/>
             </a:pPr>
             <a:r>
-              <a:rPr sz="1000" b="0">
+              <a:rPr lang="en-US" sz="820" dirty="0">
                 <a:solidFill>
                   <a:srgbClr val="1B1F3B"/>
                 </a:solidFill>
-                <a:latin typeface="Calibri"/>
+                <a:latin typeface="Calibri" pitchFamily="34" charset="0"/>
               </a:rPr>
               <a:t>Output is the Onboarding Blueprint that drives every later phase.</a:t>
             </a:r>
@@ -48080,11 +48119,11 @@
               <a:buNone/>
             </a:pPr>
             <a:r>
-              <a:rPr sz="1100" b="1">
+              <a:rPr lang="en-US" sz="890" b="1" i="0" dirty="0">
                 <a:solidFill>
                   <a:srgbClr val="FFFFFF"/>
                 </a:solidFill>
-                <a:latin typeface="Calibri"/>
+                <a:latin typeface="Calibri" pitchFamily="34" charset="0"/>
               </a:rPr>
               <a:t>2</a:t>
             </a:r>
@@ -48120,11 +48159,11 @@
               <a:buNone/>
             </a:pPr>
             <a:r>
-              <a:rPr sz="1400" b="1">
-                <a:solidFill>
-                  <a:srgbClr val="1E50AF"/>
-                </a:solidFill>
-                <a:latin typeface="Calibri"/>
+              <a:rPr lang="en-US" sz="1120" b="1" i="0" dirty="0">
+                <a:solidFill>
+                  <a:srgbClr val="2C4C9B"/>
+                </a:solidFill>
+                <a:latin typeface="Calibri" pitchFamily="34" charset="0"/>
               </a:rPr>
               <a:t>Connect</a:t>
             </a:r>
@@ -48187,11 +48226,11 @@
               <a:buChar char="•"/>
             </a:pPr>
             <a:r>
-              <a:rPr sz="1000" b="0">
+              <a:rPr lang="en-US" sz="820" dirty="0">
                 <a:solidFill>
                   <a:srgbClr val="1B1F3B"/>
                 </a:solidFill>
-                <a:latin typeface="Calibri"/>
+                <a:latin typeface="Calibri" pitchFamily="34" charset="0"/>
               </a:rPr>
               <a:t>Registers cloud accounts, repos, CI/CD, ticketing and notification channels — once.</a:t>
             </a:r>
@@ -48208,11 +48247,11 @@
               <a:buChar char="•"/>
             </a:pPr>
             <a:r>
-              <a:rPr sz="1000" b="0">
+              <a:rPr lang="en-US" sz="820" dirty="0">
                 <a:solidFill>
                   <a:srgbClr val="1B1F3B"/>
                 </a:solidFill>
-                <a:latin typeface="Calibri"/>
+                <a:latin typeface="Calibri" pitchFamily="34" charset="0"/>
               </a:rPr>
               <a:t>No credentials stored; auth via Managed Identity or Service Principal.</a:t>
             </a:r>
@@ -48368,11 +48407,11 @@
               <a:buNone/>
             </a:pPr>
             <a:r>
-              <a:rPr sz="1100" b="1">
+              <a:rPr lang="en-US" sz="890" b="1" i="0" dirty="0">
                 <a:solidFill>
                   <a:srgbClr val="FFFFFF"/>
                 </a:solidFill>
-                <a:latin typeface="Calibri"/>
+                <a:latin typeface="Calibri" pitchFamily="34" charset="0"/>
               </a:rPr>
               <a:t>3</a:t>
             </a:r>
@@ -48408,11 +48447,11 @@
               <a:buNone/>
             </a:pPr>
             <a:r>
-              <a:rPr sz="1400" b="1">
-                <a:solidFill>
-                  <a:srgbClr val="78288C"/>
-                </a:solidFill>
-                <a:latin typeface="Calibri"/>
+              <a:rPr lang="en-US" sz="1120" b="1" i="0" dirty="0">
+                <a:solidFill>
+                  <a:srgbClr val="7A3FB0"/>
+                </a:solidFill>
+                <a:latin typeface="Calibri" pitchFamily="34" charset="0"/>
               </a:rPr>
               <a:t>Configure</a:t>
             </a:r>
@@ -48475,11 +48514,11 @@
               <a:buChar char="•"/>
             </a:pPr>
             <a:r>
-              <a:rPr sz="1000" b="0">
+              <a:rPr lang="en-US" sz="820" dirty="0">
                 <a:solidFill>
                   <a:srgbClr val="1B1F3B"/>
                 </a:solidFill>
-                <a:latin typeface="Calibri"/>
+                <a:latin typeface="Calibri" pitchFamily="34" charset="0"/>
               </a:rPr>
               <a:t>Approval chains, deployment templates, promotion and validation rules.</a:t>
             </a:r>
@@ -48496,11 +48535,11 @@
               <a:buChar char="•"/>
             </a:pPr>
             <a:r>
-              <a:rPr sz="1000" b="0">
+              <a:rPr lang="en-US" sz="820" dirty="0">
                 <a:solidFill>
                   <a:srgbClr val="1B1F3B"/>
                 </a:solidFill>
-                <a:latin typeface="Calibri"/>
+                <a:latin typeface="Calibri" pitchFamily="34" charset="0"/>
               </a:rPr>
               <a:t>Defined as configuration, not code — changes apply to the very next release.</a:t>
             </a:r>
@@ -48656,11 +48695,11 @@
               <a:buNone/>
             </a:pPr>
             <a:r>
-              <a:rPr sz="1100" b="1">
+              <a:rPr lang="en-US" sz="890" b="1" i="0" dirty="0">
                 <a:solidFill>
                   <a:srgbClr val="FFFFFF"/>
                 </a:solidFill>
-                <a:latin typeface="Calibri"/>
+                <a:latin typeface="Calibri" pitchFamily="34" charset="0"/>
               </a:rPr>
               <a:t>4</a:t>
             </a:r>
@@ -48696,11 +48735,11 @@
               <a:buNone/>
             </a:pPr>
             <a:r>
-              <a:rPr sz="1400" b="1">
-                <a:solidFill>
-                  <a:srgbClr val="B42846"/>
-                </a:solidFill>
-                <a:latin typeface="Calibri"/>
+              <a:rPr lang="en-US" sz="1120" b="1" i="0" dirty="0">
+                <a:solidFill>
+                  <a:srgbClr val="AA3E6E"/>
+                </a:solidFill>
+                <a:latin typeface="Calibri" pitchFamily="34" charset="0"/>
               </a:rPr>
               <a:t>Observe</a:t>
             </a:r>
@@ -48763,11 +48802,11 @@
               <a:buChar char="•"/>
             </a:pPr>
             <a:r>
-              <a:rPr sz="1000" b="0">
+              <a:rPr lang="en-US" sz="820" dirty="0">
                 <a:solidFill>
                   <a:srgbClr val="1B1F3B"/>
                 </a:solidFill>
-                <a:latin typeface="Calibri"/>
+                <a:latin typeface="Calibri" pitchFamily="34" charset="0"/>
               </a:rPr>
               <a:t>Live dashboards, health signals, full audit trail and exportable reports.</a:t>
             </a:r>
@@ -48784,11 +48823,11 @@
               <a:buChar char="•"/>
             </a:pPr>
             <a:r>
-              <a:rPr sz="1000" b="0">
+              <a:rPr lang="en-US" sz="820" dirty="0">
                 <a:solidFill>
                   <a:srgbClr val="1B1F3B"/>
                 </a:solidFill>
-                <a:latin typeface="Calibri"/>
+                <a:latin typeface="Calibri" pitchFamily="34" charset="0"/>
               </a:rPr>
               <a:t>Every action traces back to who approved what, and when.</a:t>
             </a:r>
@@ -48906,11 +48945,11 @@
               <a:buNone/>
             </a:pPr>
             <a:r>
-              <a:rPr sz="1100" b="0">
+              <a:rPr lang="en-US" sz="880" b="0" i="0" dirty="0">
                 <a:solidFill>
                   <a:srgbClr val="FFFFFF"/>
                 </a:solidFill>
-                <a:latin typeface="Calibri"/>
+                <a:latin typeface="Calibri" pitchFamily="34" charset="0"/>
               </a:rPr>
               <a:t>One engine, always — every change resolves down through the same governed, agent-driven stack.</a:t>
             </a:r>
@@ -48979,11 +49018,11 @@
               <a:buNone/>
             </a:pPr>
             <a:r>
-              <a:rPr sz="1450" b="1">
-                <a:solidFill>
-                  <a:srgbClr val="FFFFFF"/>
-                </a:solidFill>
-                <a:latin typeface="Calibri"/>
+              <a:rPr lang="en-US" sz="980" b="1" i="0" dirty="0">
+                <a:solidFill>
+                  <a:srgbClr val="CADCFC"/>
+                </a:solidFill>
+                <a:latin typeface="Calibri" pitchFamily="34" charset="0"/>
               </a:rPr>
               <a:t>60–80%</a:t>
             </a:r>
@@ -49019,11 +49058,11 @@
               <a:buNone/>
             </a:pPr>
             <a:r>
-              <a:rPr sz="880" b="0">
-                <a:solidFill>
-                  <a:srgbClr val="B4C8E6"/>
-                </a:solidFill>
-                <a:latin typeface="Calibri"/>
+              <a:rPr lang="en-US" sz="670" b="0" i="0" dirty="0">
+                <a:solidFill>
+                  <a:srgbClr val="9FB4D8"/>
+                </a:solidFill>
+                <a:latin typeface="Calibri" pitchFamily="34" charset="0"/>
               </a:rPr>
               <a:t>faster execution</a:t>
             </a:r>
@@ -49092,11 +49131,11 @@
               <a:buNone/>
             </a:pPr>
             <a:r>
-              <a:rPr sz="1450" b="1">
-                <a:solidFill>
-                  <a:srgbClr val="FFFFFF"/>
-                </a:solidFill>
-                <a:latin typeface="Calibri"/>
+              <a:rPr lang="en-US" sz="980" b="1" i="0" dirty="0">
+                <a:solidFill>
+                  <a:srgbClr val="CADCFC"/>
+                </a:solidFill>
+                <a:latin typeface="Calibri" pitchFamily="34" charset="0"/>
               </a:rPr>
               <a:t>2–4×</a:t>
             </a:r>
@@ -49132,11 +49171,11 @@
               <a:buNone/>
             </a:pPr>
             <a:r>
-              <a:rPr sz="880" b="0">
-                <a:solidFill>
-                  <a:srgbClr val="B4C8E6"/>
-                </a:solidFill>
-                <a:latin typeface="Calibri"/>
+              <a:rPr lang="en-US" sz="670" b="0" i="0" dirty="0">
+                <a:solidFill>
+                  <a:srgbClr val="9FB4D8"/>
+                </a:solidFill>
+                <a:latin typeface="Calibri" pitchFamily="34" charset="0"/>
               </a:rPr>
               <a:t>release frequency</a:t>
             </a:r>
@@ -49205,11 +49244,11 @@
               <a:buNone/>
             </a:pPr>
             <a:r>
-              <a:rPr sz="1450" b="1">
-                <a:solidFill>
-                  <a:srgbClr val="FFFFFF"/>
-                </a:solidFill>
-                <a:latin typeface="Calibri"/>
+              <a:rPr lang="en-US" sz="980" b="1" i="0" dirty="0">
+                <a:solidFill>
+                  <a:srgbClr val="CADCFC"/>
+                </a:solidFill>
+                <a:latin typeface="Calibri" pitchFamily="34" charset="0"/>
               </a:rPr>
               <a:t>100%</a:t>
             </a:r>
@@ -49245,11 +49284,11 @@
               <a:buNone/>
             </a:pPr>
             <a:r>
-              <a:rPr sz="880" b="0">
-                <a:solidFill>
-                  <a:srgbClr val="B4C8E6"/>
-                </a:solidFill>
-                <a:latin typeface="Calibri"/>
+              <a:rPr lang="en-US" sz="670" b="0" i="0" dirty="0">
+                <a:solidFill>
+                  <a:srgbClr val="9FB4D8"/>
+                </a:solidFill>
+                <a:latin typeface="Calibri" pitchFamily="34" charset="0"/>
               </a:rPr>
               <a:t>audit coverage</a:t>
             </a:r>

</xml_diff>